<commit_message>
Many tries to bypass power point generation from skill template
</commit_message>
<xml_diff>
--- a/skills/qarag-pptx-reporter-skill-assets/QA_Delivery_Health_Status_Report_Template_-_Optimized.pptx
+++ b/skills/qarag-pptx-reporter-skill-assets/QA_Delivery_Health_Status_Report_Template_-_Optimized.pptx
@@ -3703,9 +3703,7 @@
             <a:avLst/>
           </a:prstGeom>
           <a:solidFill>
-            <a:schemeClr val="accent6">
-              <a:lumMod val="75000"/>
-            </a:schemeClr>
+            <a:srgbClr val="FF7701"/>
           </a:solidFill>
         </p:spPr>
         <p:txBody>

</xml_diff>